<commit_message>
feat(export): connect board deck family and close visual parity [B]
</commit_message>
<xml_diff>
--- a/docs/program/EXPORT_1_PPTX_20260916/dowody/northwind-board-deck.pptx
+++ b/docs/program/EXPORT_1_PPTX_20260916/dowody/northwind-board-deck.pptx
@@ -158,11 +158,12 @@
                     <a:solidFill>
                       <a:srgbClr val="000000"/>
                     </a:solidFill>
-                    <a:latin typeface="Arial"/>
+                    <a:latin typeface="+mn-lt"/>
                   </a:defRPr>
                 </a:pPr>
               </a:p>
             </c:txPr>
+            <c:dLblPos val="outEnd"/>
             <c:showLegendKey val="0"/>
             <c:showVal val="1"/>
             <c:showCatName val="0"/>
@@ -171,72 +172,6 @@
             <c:showBubbleSize val="0"/>
             <c:showLeaderLines val="0"/>
           </c:dLbls>
-          <c:dPt>
-            <c:idx val="0"/>
-            <c:invertIfNegative val="0"/>
-            <c:bubble3D val="0"/>
-            <c:spPr>
-              <a:solidFill>
-                <a:srgbClr val="2563EB"/>
-              </a:solidFill>
-              <a:effectLst/>
-            </c:spPr>
-          </c:dPt>
-          <c:dPt>
-            <c:idx val="1"/>
-            <c:invertIfNegative val="0"/>
-            <c:bubble3D val="0"/>
-            <c:spPr>
-              <a:solidFill>
-                <a:srgbClr val="1B2A41"/>
-              </a:solidFill>
-              <a:effectLst/>
-            </c:spPr>
-          </c:dPt>
-          <c:dPt>
-            <c:idx val="2"/>
-            <c:invertIfNegative val="0"/>
-            <c:bubble3D val="0"/>
-            <c:spPr>
-              <a:solidFill>
-                <a:srgbClr val="7DA7FF"/>
-              </a:solidFill>
-              <a:effectLst/>
-            </c:spPr>
-          </c:dPt>
-          <c:dPt>
-            <c:idx val="3"/>
-            <c:invertIfNegative val="0"/>
-            <c:bubble3D val="0"/>
-            <c:spPr>
-              <a:solidFill>
-                <a:srgbClr val="2563EB"/>
-              </a:solidFill>
-              <a:effectLst/>
-            </c:spPr>
-          </c:dPt>
-          <c:dPt>
-            <c:idx val="4"/>
-            <c:invertIfNegative val="0"/>
-            <c:bubble3D val="0"/>
-            <c:spPr>
-              <a:solidFill>
-                <a:srgbClr val="1B2A41"/>
-              </a:solidFill>
-              <a:effectLst/>
-            </c:spPr>
-          </c:dPt>
-          <c:dPt>
-            <c:idx val="5"/>
-            <c:invertIfNegative val="0"/>
-            <c:bubble3D val="0"/>
-            <c:spPr>
-              <a:solidFill>
-                <a:srgbClr val="7DA7FF"/>
-              </a:solidFill>
-              <a:effectLst/>
-            </c:spPr>
-          </c:dPt>
           <c:cat>
             <c:multiLvlStrRef>
               <c:f>Sheet1!$A$2:$A$7</c:f>
@@ -304,11 +239,12 @@
                   <a:solidFill>
                     <a:srgbClr val="000000"/>
                   </a:solidFill>
-                  <a:latin typeface="Arial"/>
+                  <a:latin typeface="+mn-lt"/>
                 </a:defRPr>
               </a:pPr>
             </a:p>
           </c:txPr>
+          <c:dLblPos val="outEnd"/>
           <c:showLegendKey val="0"/>
           <c:showVal val="1"/>
           <c:showCatName val="0"/>
@@ -317,12 +253,169 @@
           <c:showBubbleSize val="0"/>
           <c:showLeaderLines val="0"/>
         </c:dLbls>
-        <c:gapWidth val="150"/>
+        <c:gapWidth val="55"/>
         <c:overlap val="0"/>
         <c:axId val="2094734554"/>
         <c:axId val="2094734552"/>
         <c:axId val="2094734556"/>
       </c:barChart>
+      <c:lineChart>
+        <c:varyColors val="0"/>
+        <c:ser>
+          <c:idx val="1"/>
+          <c:order val="1"/>
+          <c:tx>
+            <c:strRef>
+              <c:f>Sheet1!$C$1</c:f>
+              <c:strCache>
+                <c:ptCount val="1"/>
+                <c:pt idx="0">
+                  <c:v>Target 78%</c:v>
+                </c:pt>
+              </c:strCache>
+            </c:strRef>
+          </c:tx>
+          <c:spPr>
+            <a:solidFill>
+              <a:srgbClr val="667085"/>
+            </a:solidFill>
+            <a:ln w="19050" cap="flat">
+              <a:solidFill>
+                <a:srgbClr val="667085"/>
+              </a:solidFill>
+              <a:prstDash val="dash"/>
+              <a:round/>
+            </a:ln>
+            <a:effectLst/>
+          </c:spPr>
+          <c:invertIfNegative val="0"/>
+          <c:dLbls>
+            <c:numFmt formatCode="#,##0" sourceLinked="0"/>
+            <c:txPr>
+              <a:bodyPr/>
+              <a:lstStyle/>
+              <a:p>
+                <a:pPr>
+                  <a:defRPr b="0" i="0" strike="noStrike" sz="1200" u="none">
+                    <a:solidFill>
+                      <a:srgbClr val="000000"/>
+                    </a:solidFill>
+                    <a:latin typeface="+mn-lt"/>
+                  </a:defRPr>
+                </a:pPr>
+              </a:p>
+            </c:txPr>
+            <c:showLegendKey val="0"/>
+            <c:showVal val="0"/>
+            <c:showCatName val="0"/>
+            <c:showSerName val="0"/>
+            <c:showPercent val="0"/>
+            <c:showBubbleSize val="0"/>
+            <c:showLeaderLines val="0"/>
+          </c:dLbls>
+          <c:marker>
+            <c:symbol val="none"/>
+            <c:size val="6"/>
+            <c:spPr>
+              <a:solidFill>
+                <a:srgbClr val="667085"/>
+              </a:solidFill>
+              <a:ln w="9525" cap="flat">
+                <a:solidFill>
+                  <a:srgbClr val="667085"/>
+                </a:solidFill>
+                <a:prstDash val="solid"/>
+                <a:round/>
+              </a:ln>
+              <a:effectLst/>
+            </c:spPr>
+          </c:marker>
+          <c:cat>
+            <c:multiLvlStrRef>
+              <c:f>Sheet1!$A$2:$A$7</c:f>
+              <c:multiLvlStrCache>
+                <c:ptCount val="6"/>
+                <c:lvl>
+                  <c:pt idx="0">
+                    <c:v>Jan</c:v>
+                  </c:pt>
+                  <c:pt idx="1">
+                    <c:v>Feb</c:v>
+                  </c:pt>
+                  <c:pt idx="2">
+                    <c:v>Mar</c:v>
+                  </c:pt>
+                  <c:pt idx="3">
+                    <c:v>Apr</c:v>
+                  </c:pt>
+                  <c:pt idx="4">
+                    <c:v>May</c:v>
+                  </c:pt>
+                  <c:pt idx="5">
+                    <c:v>Jun</c:v>
+                  </c:pt>
+                </c:lvl>
+              </c:multiLvlStrCache>
+            </c:multiLvlStrRef>
+          </c:cat>
+          <c:val>
+            <c:numRef>
+              <c:f>Sheet1!$C$2:$C$7</c:f>
+              <c:numCache>
+                <c:formatCode>General</c:formatCode>
+                <c:ptCount val="6"/>
+                <c:pt idx="0">
+                  <c:v>78</c:v>
+                </c:pt>
+                <c:pt idx="1">
+                  <c:v>78</c:v>
+                </c:pt>
+                <c:pt idx="2">
+                  <c:v>78</c:v>
+                </c:pt>
+                <c:pt idx="3">
+                  <c:v>78</c:v>
+                </c:pt>
+                <c:pt idx="4">
+                  <c:v>78</c:v>
+                </c:pt>
+                <c:pt idx="5">
+                  <c:v>78</c:v>
+                </c:pt>
+              </c:numCache>
+            </c:numRef>
+          </c:val>
+          <c:smooth val="0"/>
+        </c:ser>
+        <c:dLbls>
+          <c:numFmt formatCode="#,##0" sourceLinked="0"/>
+          <c:txPr>
+            <a:bodyPr/>
+            <a:lstStyle/>
+            <a:p>
+              <a:pPr>
+                <a:defRPr b="0" i="0" strike="noStrike" sz="1200" u="none">
+                  <a:solidFill>
+                    <a:srgbClr val="000000"/>
+                  </a:solidFill>
+                  <a:latin typeface="+mn-lt"/>
+                </a:defRPr>
+              </a:pPr>
+            </a:p>
+          </c:txPr>
+          <c:showLegendKey val="0"/>
+          <c:showVal val="0"/>
+          <c:showCatName val="0"/>
+          <c:showSerName val="0"/>
+          <c:showPercent val="0"/>
+          <c:showBubbleSize val="0"/>
+          <c:showLeaderLines val="0"/>
+        </c:dLbls>
+        <c:marker val="1"/>
+        <c:axId val="2094734554"/>
+        <c:axId val="2094734552"/>
+        <c:axId val="2094734556"/>
+      </c:lineChart>
       <c:catAx>
         <c:axId val="2094734554"/>
         <c:scaling>
@@ -352,7 +445,7 @@
                 <a:solidFill>
                   <a:srgbClr val="000000"/>
                 </a:solidFill>
-                <a:latin typeface="Arial"/>
+                <a:latin typeface="+mn-lt"/>
               </a:defRPr>
             </a:pPr>
             <a:endParaRPr lang="en-US"/>
@@ -404,7 +497,7 @@
                 <a:solidFill>
                   <a:srgbClr val="000000"/>
                 </a:solidFill>
-                <a:latin typeface="Arial"/>
+                <a:latin typeface="+mn-lt"/>
               </a:defRPr>
             </a:pPr>
             <a:endParaRPr lang="en-US"/>
@@ -1571,7 +1664,7 @@
         <a:spcBef>
           <a:spcPct val="20000"/>
         </a:spcBef>
-        <a:buFont typeface="Arial" pitchFamily="34" charset="0"/>
+        <a:buFont typeface="+mn-lt" pitchFamily="34" charset="0"/>
         <a:buChar char="•"/>
         <a:defRPr sz="3200" kern="1200">
           <a:solidFill>
@@ -1586,7 +1679,7 @@
         <a:spcBef>
           <a:spcPct val="20000"/>
         </a:spcBef>
-        <a:buFont typeface="Arial" pitchFamily="34" charset="0"/>
+        <a:buFont typeface="+mn-lt" pitchFamily="34" charset="0"/>
         <a:buChar char="–"/>
         <a:defRPr sz="2800" kern="1200">
           <a:solidFill>
@@ -1601,7 +1694,7 @@
         <a:spcBef>
           <a:spcPct val="20000"/>
         </a:spcBef>
-        <a:buFont typeface="Arial" pitchFamily="34" charset="0"/>
+        <a:buFont typeface="+mn-lt" pitchFamily="34" charset="0"/>
         <a:buChar char="•"/>
         <a:defRPr sz="2400" kern="1200">
           <a:solidFill>
@@ -1616,7 +1709,7 @@
         <a:spcBef>
           <a:spcPct val="20000"/>
         </a:spcBef>
-        <a:buFont typeface="Arial" pitchFamily="34" charset="0"/>
+        <a:buFont typeface="+mn-lt" pitchFamily="34" charset="0"/>
         <a:buChar char="–"/>
         <a:defRPr sz="2000" kern="1200">
           <a:solidFill>
@@ -1631,7 +1724,7 @@
         <a:spcBef>
           <a:spcPct val="20000"/>
         </a:spcBef>
-        <a:buFont typeface="Arial" pitchFamily="34" charset="0"/>
+        <a:buFont typeface="+mn-lt" pitchFamily="34" charset="0"/>
         <a:buChar char="»"/>
         <a:defRPr sz="2000" kern="1200">
           <a:solidFill>
@@ -1646,7 +1739,7 @@
         <a:spcBef>
           <a:spcPct val="20000"/>
         </a:spcBef>
-        <a:buFont typeface="Arial" pitchFamily="34" charset="0"/>
+        <a:buFont typeface="+mn-lt" pitchFamily="34" charset="0"/>
         <a:buChar char="•"/>
         <a:defRPr sz="2000" kern="1200">
           <a:solidFill>
@@ -1661,7 +1754,7 @@
         <a:spcBef>
           <a:spcPct val="20000"/>
         </a:spcBef>
-        <a:buFont typeface="Arial" pitchFamily="34" charset="0"/>
+        <a:buFont typeface="+mn-lt" pitchFamily="34" charset="0"/>
         <a:buChar char="•"/>
         <a:defRPr sz="2000" kern="1200">
           <a:solidFill>
@@ -1676,7 +1769,7 @@
         <a:spcBef>
           <a:spcPct val="20000"/>
         </a:spcBef>
-        <a:buFont typeface="Arial" pitchFamily="34" charset="0"/>
+        <a:buFont typeface="+mn-lt" pitchFamily="34" charset="0"/>
         <a:buChar char="•"/>
         <a:defRPr sz="2000" kern="1200">
           <a:solidFill>
@@ -1691,7 +1784,7 @@
         <a:spcBef>
           <a:spcPct val="20000"/>
         </a:spcBef>
-        <a:buFont typeface="Arial" pitchFamily="34" charset="0"/>
+        <a:buFont typeface="+mn-lt" pitchFamily="34" charset="0"/>
         <a:buChar char="•"/>
         <a:defRPr sz="2000" kern="1200">
           <a:solidFill>
@@ -3273,8 +3366,44 @@
         </p:nvSpPr>
         <p:spPr>
           <a:xfrm>
-            <a:off x="1097280" y="5504688"/>
-            <a:ext cx="9829800" cy="292608"/>
+            <a:off x="1097280" y="5449824"/>
+            <a:ext cx="1828800" cy="146304"/>
+          </a:xfrm>
+          <a:prstGeom prst="rect">
+            <a:avLst/>
+          </a:prstGeom>
+          <a:noFill/>
+          <a:ln/>
+        </p:spPr>
+        <p:txBody>
+          <a:bodyPr wrap="square" lIns="0" tIns="0" rIns="0" bIns="0" rtlCol="0" anchor="ctr"/>
+          <a:lstStyle/>
+          <a:p>
+            <a:pPr indent="0" marL="0">
+              <a:buNone/>
+            </a:pPr>
+            <a:r>
+              <a:rPr lang="en-US" sz="650" b="1" spc="120" kern="0" dirty="0">
+                <a:solidFill>
+                  <a:srgbClr val="2563EB"/>
+                </a:solidFill>
+              </a:rPr>
+              <a:t>SO WHAT</a:t>
+            </a:r>
+            <a:endParaRPr lang="en-US" sz="650" dirty="0"/>
+          </a:p>
+        </p:txBody>
+      </p:sp>
+      <p:sp>
+        <p:nvSpPr>
+          <p:cNvPr id="9" name="Text 7"/>
+          <p:cNvSpPr/>
+          <p:nvPr/>
+        </p:nvSpPr>
+        <p:spPr>
+          <a:xfrm>
+            <a:off x="1097280" y="5623560"/>
+            <a:ext cx="9829800" cy="237744"/>
           </a:xfrm>
           <a:prstGeom prst="rect">
             <a:avLst/>
@@ -3305,7 +3434,7 @@
       </p:sp>
       <p:sp>
         <p:nvSpPr>
-          <p:cNvPr id="9" name="Shape 7"/>
+          <p:cNvPr id="10" name="Shape 8"/>
           <p:cNvSpPr/>
           <p:nvPr/>
         </p:nvSpPr>
@@ -3328,7 +3457,7 @@
       </p:sp>
       <p:sp>
         <p:nvSpPr>
-          <p:cNvPr id="10" name="Text 8"/>
+          <p:cNvPr id="11" name="Text 9"/>
           <p:cNvSpPr/>
           <p:nvPr/>
         </p:nvSpPr>
@@ -3364,7 +3493,7 @@
       </p:sp>
       <p:sp>
         <p:nvSpPr>
-          <p:cNvPr id="11" name="Text 9"/>
+          <p:cNvPr id="12" name="Text 10"/>
           <p:cNvSpPr/>
           <p:nvPr/>
         </p:nvSpPr>
@@ -4073,7 +4202,7 @@
         </p:nvGraphicFramePr>
         <p:xfrm>
           <a:off x="868680" y="1417320"/>
-          <a:ext cx="10378440" cy="4434840"/>
+          <a:ext cx="10378440" cy="914400"/>
         </p:xfrm>
         <a:graphic>
           <a:graphicData uri="http://schemas.openxmlformats.org/drawingml/2006/table">
@@ -4086,7 +4215,7 @@
                 <a:gridCol w="731520"/>
                 <a:gridCol w="4892040"/>
               </a:tblGrid>
-              <a:tr h="886968">
+              <a:tr h="384048">
                 <a:tc>
                   <a:txBody>
                     <a:bodyPr/>
@@ -4393,7 +4522,7 @@
                   </a:tcPr>
                 </a:tc>
               </a:tr>
-              <a:tr h="886968">
+              <a:tr h="384048">
                 <a:tc>
                   <a:txBody>
                     <a:bodyPr/>
@@ -4403,9 +4532,9 @@
                         <a:buNone/>
                       </a:pPr>
                       <a:r>
-                        <a:rPr lang="en-US" sz="900" dirty="0">
+                        <a:rPr lang="en-US" sz="900" b="1" dirty="0">
                           <a:solidFill>
-                            <a:srgbClr val="101828"/>
+                            <a:srgbClr val="1B2A41"/>
                           </a:solidFill>
                         </a:rPr>
                         <a:t>Engagement lead</a:t>
@@ -4700,7 +4829,7 @@
                   </a:tcPr>
                 </a:tc>
               </a:tr>
-              <a:tr h="886968">
+              <a:tr h="384048">
                 <a:tc>
                   <a:txBody>
                     <a:bodyPr/>
@@ -4710,9 +4839,9 @@
                         <a:buNone/>
                       </a:pPr>
                       <a:r>
-                        <a:rPr lang="en-US" sz="900" dirty="0">
+                        <a:rPr lang="en-US" sz="900" b="1" dirty="0">
                           <a:solidFill>
-                            <a:srgbClr val="101828"/>
+                            <a:srgbClr val="1B2A41"/>
                           </a:solidFill>
                         </a:rPr>
                         <a:t>Operations analyst</a:t>
@@ -4758,7 +4887,7 @@
                       <a:tailEnd type="none" w="med" len="med"/>
                     </a:lnB>
                     <a:solidFill>
-                      <a:srgbClr val="FFFFFF"/>
+                      <a:srgbClr val="F1F4F8"/>
                     </a:solidFill>
                   </a:tcPr>
                 </a:tc>
@@ -4819,7 +4948,7 @@
                       <a:tailEnd type="none" w="med" len="med"/>
                     </a:lnB>
                     <a:solidFill>
-                      <a:srgbClr val="FFFFFF"/>
+                      <a:srgbClr val="F1F4F8"/>
                     </a:solidFill>
                   </a:tcPr>
                 </a:tc>
@@ -4880,7 +5009,7 @@
                       <a:tailEnd type="none" w="med" len="med"/>
                     </a:lnB>
                     <a:solidFill>
-                      <a:srgbClr val="FFFFFF"/>
+                      <a:srgbClr val="F1F4F8"/>
                     </a:solidFill>
                   </a:tcPr>
                 </a:tc>
@@ -4941,7 +5070,7 @@
                       <a:tailEnd type="none" w="med" len="med"/>
                     </a:lnB>
                     <a:solidFill>
-                      <a:srgbClr val="FFFFFF"/>
+                      <a:srgbClr val="F1F4F8"/>
                     </a:solidFill>
                   </a:tcPr>
                 </a:tc>
@@ -5002,12 +5131,12 @@
                       <a:tailEnd type="none" w="med" len="med"/>
                     </a:lnB>
                     <a:solidFill>
-                      <a:srgbClr val="FFFFFF"/>
+                      <a:srgbClr val="F1F4F8"/>
                     </a:solidFill>
                   </a:tcPr>
                 </a:tc>
               </a:tr>
-              <a:tr h="886968">
+              <a:tr h="384048">
                 <a:tc>
                   <a:txBody>
                     <a:bodyPr/>
@@ -5017,9 +5146,9 @@
                         <a:buNone/>
                       </a:pPr>
                       <a:r>
-                        <a:rPr lang="en-US" sz="900" dirty="0">
+                        <a:rPr lang="en-US" sz="900" b="1" dirty="0">
                           <a:solidFill>
-                            <a:srgbClr val="101828"/>
+                            <a:srgbClr val="1B2A41"/>
                           </a:solidFill>
                         </a:rPr>
                         <a:t>Quality engineer</a:t>
@@ -5314,7 +5443,68 @@
                   </a:tcPr>
                 </a:tc>
               </a:tr>
-              <a:tr h="886968">
+              <a:tr h="566928">
+                <a:tc>
+                  <a:txBody>
+                    <a:bodyPr/>
+                    <a:lstStyle/>
+                    <a:p>
+                      <a:pPr indent="0" marL="0">
+                        <a:buNone/>
+                      </a:pPr>
+                      <a:r>
+                        <a:rPr lang="en-US" sz="900" b="1" dirty="0">
+                          <a:solidFill>
+                            <a:srgbClr val="1B2A41"/>
+                          </a:solidFill>
+                        </a:rPr>
+                        <a:t>Data engineer</a:t>
+                      </a:r>
+                      <a:endParaRPr lang="en-US" sz="900" dirty="0"/>
+                    </a:p>
+                  </a:txBody>
+                  <a:tcPr marL="73152" marR="73152" marT="73152" marB="73152">
+                    <a:lnL w="6350" cap="flat" cmpd="sng" algn="ctr">
+                      <a:solidFill>
+                        <a:srgbClr val="D8DEE8"/>
+                      </a:solidFill>
+                      <a:prstDash val="solid"/>
+                      <a:round/>
+                      <a:headEnd type="none" w="med" len="med"/>
+                      <a:tailEnd type="none" w="med" len="med"/>
+                    </a:lnL>
+                    <a:lnR w="6350" cap="flat" cmpd="sng" algn="ctr">
+                      <a:solidFill>
+                        <a:srgbClr val="D8DEE8"/>
+                      </a:solidFill>
+                      <a:prstDash val="solid"/>
+                      <a:round/>
+                      <a:headEnd type="none" w="med" len="med"/>
+                      <a:tailEnd type="none" w="med" len="med"/>
+                    </a:lnR>
+                    <a:lnT w="6350" cap="flat" cmpd="sng" algn="ctr">
+                      <a:solidFill>
+                        <a:srgbClr val="D8DEE8"/>
+                      </a:solidFill>
+                      <a:prstDash val="solid"/>
+                      <a:round/>
+                      <a:headEnd type="none" w="med" len="med"/>
+                      <a:tailEnd type="none" w="med" len="med"/>
+                    </a:lnT>
+                    <a:lnB w="6350" cap="flat" cmpd="sng" algn="ctr">
+                      <a:solidFill>
+                        <a:srgbClr val="D8DEE8"/>
+                      </a:solidFill>
+                      <a:prstDash val="solid"/>
+                      <a:round/>
+                      <a:headEnd type="none" w="med" len="med"/>
+                      <a:tailEnd type="none" w="med" len="med"/>
+                    </a:lnB>
+                    <a:solidFill>
+                      <a:srgbClr val="F1F4F8"/>
+                    </a:solidFill>
+                  </a:tcPr>
+                </a:tc>
                 <a:tc>
                   <a:txBody>
                     <a:bodyPr/>
@@ -5329,7 +5519,253 @@
                             <a:srgbClr val="101828"/>
                           </a:solidFill>
                         </a:rPr>
-                        <a:t>Data engineer</a:t>
+                        <a:t>Digital and Data</a:t>
+                      </a:r>
+                      <a:endParaRPr lang="en-US" sz="900" dirty="0"/>
+                    </a:p>
+                  </a:txBody>
+                  <a:tcPr marL="73152" marR="73152" marT="73152" marB="73152">
+                    <a:lnL w="6350" cap="flat" cmpd="sng" algn="ctr">
+                      <a:solidFill>
+                        <a:srgbClr val="D8DEE8"/>
+                      </a:solidFill>
+                      <a:prstDash val="solid"/>
+                      <a:round/>
+                      <a:headEnd type="none" w="med" len="med"/>
+                      <a:tailEnd type="none" w="med" len="med"/>
+                    </a:lnL>
+                    <a:lnR w="6350" cap="flat" cmpd="sng" algn="ctr">
+                      <a:solidFill>
+                        <a:srgbClr val="D8DEE8"/>
+                      </a:solidFill>
+                      <a:prstDash val="solid"/>
+                      <a:round/>
+                      <a:headEnd type="none" w="med" len="med"/>
+                      <a:tailEnd type="none" w="med" len="med"/>
+                    </a:lnR>
+                    <a:lnT w="6350" cap="flat" cmpd="sng" algn="ctr">
+                      <a:solidFill>
+                        <a:srgbClr val="D8DEE8"/>
+                      </a:solidFill>
+                      <a:prstDash val="solid"/>
+                      <a:round/>
+                      <a:headEnd type="none" w="med" len="med"/>
+                      <a:tailEnd type="none" w="med" len="med"/>
+                    </a:lnT>
+                    <a:lnB w="6350" cap="flat" cmpd="sng" algn="ctr">
+                      <a:solidFill>
+                        <a:srgbClr val="D8DEE8"/>
+                      </a:solidFill>
+                      <a:prstDash val="solid"/>
+                      <a:round/>
+                      <a:headEnd type="none" w="med" len="med"/>
+                      <a:tailEnd type="none" w="med" len="med"/>
+                    </a:lnB>
+                    <a:solidFill>
+                      <a:srgbClr val="F1F4F8"/>
+                    </a:solidFill>
+                  </a:tcPr>
+                </a:tc>
+                <a:tc>
+                  <a:txBody>
+                    <a:bodyPr/>
+                    <a:lstStyle/>
+                    <a:p>
+                      <a:pPr indent="0" marL="0">
+                        <a:buNone/>
+                      </a:pPr>
+                      <a:r>
+                        <a:rPr lang="en-US" sz="900" dirty="0">
+                          <a:solidFill>
+                            <a:srgbClr val="101828"/>
+                          </a:solidFill>
+                        </a:rPr>
+                        <a:t>1</a:t>
+                      </a:r>
+                      <a:endParaRPr lang="en-US" sz="900" dirty="0"/>
+                    </a:p>
+                  </a:txBody>
+                  <a:tcPr marL="73152" marR="73152" marT="73152" marB="73152">
+                    <a:lnL w="6350" cap="flat" cmpd="sng" algn="ctr">
+                      <a:solidFill>
+                        <a:srgbClr val="D8DEE8"/>
+                      </a:solidFill>
+                      <a:prstDash val="solid"/>
+                      <a:round/>
+                      <a:headEnd type="none" w="med" len="med"/>
+                      <a:tailEnd type="none" w="med" len="med"/>
+                    </a:lnL>
+                    <a:lnR w="6350" cap="flat" cmpd="sng" algn="ctr">
+                      <a:solidFill>
+                        <a:srgbClr val="D8DEE8"/>
+                      </a:solidFill>
+                      <a:prstDash val="solid"/>
+                      <a:round/>
+                      <a:headEnd type="none" w="med" len="med"/>
+                      <a:tailEnd type="none" w="med" len="med"/>
+                    </a:lnR>
+                    <a:lnT w="6350" cap="flat" cmpd="sng" algn="ctr">
+                      <a:solidFill>
+                        <a:srgbClr val="D8DEE8"/>
+                      </a:solidFill>
+                      <a:prstDash val="solid"/>
+                      <a:round/>
+                      <a:headEnd type="none" w="med" len="med"/>
+                      <a:tailEnd type="none" w="med" len="med"/>
+                    </a:lnT>
+                    <a:lnB w="6350" cap="flat" cmpd="sng" algn="ctr">
+                      <a:solidFill>
+                        <a:srgbClr val="D8DEE8"/>
+                      </a:solidFill>
+                      <a:prstDash val="solid"/>
+                      <a:round/>
+                      <a:headEnd type="none" w="med" len="med"/>
+                      <a:tailEnd type="none" w="med" len="med"/>
+                    </a:lnB>
+                    <a:solidFill>
+                      <a:srgbClr val="F1F4F8"/>
+                    </a:solidFill>
+                  </a:tcPr>
+                </a:tc>
+                <a:tc>
+                  <a:txBody>
+                    <a:bodyPr/>
+                    <a:lstStyle/>
+                    <a:p>
+                      <a:pPr indent="0" marL="0">
+                        <a:buNone/>
+                      </a:pPr>
+                      <a:r>
+                        <a:rPr lang="en-US" sz="900" dirty="0">
+                          <a:solidFill>
+                            <a:srgbClr val="101828"/>
+                          </a:solidFill>
+                        </a:rPr>
+                        <a:t>24</a:t>
+                      </a:r>
+                      <a:endParaRPr lang="en-US" sz="900" dirty="0"/>
+                    </a:p>
+                  </a:txBody>
+                  <a:tcPr marL="73152" marR="73152" marT="73152" marB="73152">
+                    <a:lnL w="6350" cap="flat" cmpd="sng" algn="ctr">
+                      <a:solidFill>
+                        <a:srgbClr val="D8DEE8"/>
+                      </a:solidFill>
+                      <a:prstDash val="solid"/>
+                      <a:round/>
+                      <a:headEnd type="none" w="med" len="med"/>
+                      <a:tailEnd type="none" w="med" len="med"/>
+                    </a:lnL>
+                    <a:lnR w="6350" cap="flat" cmpd="sng" algn="ctr">
+                      <a:solidFill>
+                        <a:srgbClr val="D8DEE8"/>
+                      </a:solidFill>
+                      <a:prstDash val="solid"/>
+                      <a:round/>
+                      <a:headEnd type="none" w="med" len="med"/>
+                      <a:tailEnd type="none" w="med" len="med"/>
+                    </a:lnR>
+                    <a:lnT w="6350" cap="flat" cmpd="sng" algn="ctr">
+                      <a:solidFill>
+                        <a:srgbClr val="D8DEE8"/>
+                      </a:solidFill>
+                      <a:prstDash val="solid"/>
+                      <a:round/>
+                      <a:headEnd type="none" w="med" len="med"/>
+                      <a:tailEnd type="none" w="med" len="med"/>
+                    </a:lnT>
+                    <a:lnB w="6350" cap="flat" cmpd="sng" algn="ctr">
+                      <a:solidFill>
+                        <a:srgbClr val="D8DEE8"/>
+                      </a:solidFill>
+                      <a:prstDash val="solid"/>
+                      <a:round/>
+                      <a:headEnd type="none" w="med" len="med"/>
+                      <a:tailEnd type="none" w="med" len="med"/>
+                    </a:lnB>
+                    <a:solidFill>
+                      <a:srgbClr val="F1F4F8"/>
+                    </a:solidFill>
+                  </a:tcPr>
+                </a:tc>
+                <a:tc>
+                  <a:txBody>
+                    <a:bodyPr/>
+                    <a:lstStyle/>
+                    <a:p>
+                      <a:pPr indent="0" marL="0">
+                        <a:buNone/>
+                      </a:pPr>
+                      <a:r>
+                        <a:rPr lang="en-US" sz="900" dirty="0">
+                          <a:solidFill>
+                            <a:srgbClr val="101828"/>
+                          </a:solidFill>
+                        </a:rPr>
+                        <a:t>Shared production/quality data layer</a:t>
+                      </a:r>
+                      <a:endParaRPr lang="en-US" sz="900" dirty="0"/>
+                    </a:p>
+                  </a:txBody>
+                  <a:tcPr marL="73152" marR="73152" marT="73152" marB="73152">
+                    <a:lnL w="6350" cap="flat" cmpd="sng" algn="ctr">
+                      <a:solidFill>
+                        <a:srgbClr val="D8DEE8"/>
+                      </a:solidFill>
+                      <a:prstDash val="solid"/>
+                      <a:round/>
+                      <a:headEnd type="none" w="med" len="med"/>
+                      <a:tailEnd type="none" w="med" len="med"/>
+                    </a:lnL>
+                    <a:lnR w="6350" cap="flat" cmpd="sng" algn="ctr">
+                      <a:solidFill>
+                        <a:srgbClr val="D8DEE8"/>
+                      </a:solidFill>
+                      <a:prstDash val="solid"/>
+                      <a:round/>
+                      <a:headEnd type="none" w="med" len="med"/>
+                      <a:tailEnd type="none" w="med" len="med"/>
+                    </a:lnR>
+                    <a:lnT w="6350" cap="flat" cmpd="sng" algn="ctr">
+                      <a:solidFill>
+                        <a:srgbClr val="D8DEE8"/>
+                      </a:solidFill>
+                      <a:prstDash val="solid"/>
+                      <a:round/>
+                      <a:headEnd type="none" w="med" len="med"/>
+                      <a:tailEnd type="none" w="med" len="med"/>
+                    </a:lnT>
+                    <a:lnB w="6350" cap="flat" cmpd="sng" algn="ctr">
+                      <a:solidFill>
+                        <a:srgbClr val="D8DEE8"/>
+                      </a:solidFill>
+                      <a:prstDash val="solid"/>
+                      <a:round/>
+                      <a:headEnd type="none" w="med" len="med"/>
+                      <a:tailEnd type="none" w="med" len="med"/>
+                    </a:lnB>
+                    <a:solidFill>
+                      <a:srgbClr val="F1F4F8"/>
+                    </a:solidFill>
+                  </a:tcPr>
+                </a:tc>
+              </a:tr>
+              <a:tr h="384048">
+                <a:tc>
+                  <a:txBody>
+                    <a:bodyPr/>
+                    <a:lstStyle/>
+                    <a:p>
+                      <a:pPr indent="0" marL="0">
+                        <a:buNone/>
+                      </a:pPr>
+                      <a:r>
+                        <a:rPr lang="en-US" sz="900" b="1" dirty="0">
+                          <a:solidFill>
+                            <a:srgbClr val="1B2A41"/>
+                          </a:solidFill>
+                        </a:rPr>
+                        <a:t>OT security lead</a:t>
                       </a:r>
                       <a:endParaRPr lang="en-US" sz="900" dirty="0"/>
                     </a:p>
@@ -5451,7 +5887,7 @@
                             <a:srgbClr val="101828"/>
                           </a:solidFill>
                         </a:rPr>
-                        <a:t>1</a:t>
+                        <a:t>0.3</a:t>
                       </a:r>
                       <a:endParaRPr lang="en-US" sz="900" dirty="0"/>
                     </a:p>
@@ -5512,7 +5948,7 @@
                             <a:srgbClr val="101828"/>
                           </a:solidFill>
                         </a:rPr>
-                        <a:t>24</a:t>
+                        <a:t>12</a:t>
                       </a:r>
                       <a:endParaRPr lang="en-US" sz="900" dirty="0"/>
                     </a:p>
@@ -5573,7 +6009,7 @@
                             <a:srgbClr val="101828"/>
                           </a:solidFill>
                         </a:rPr>
-                        <a:t>Shared production/quality data layer</a:t>
+                        <a:t>OT/IT segmentation hardening</a:t>
                       </a:r>
                       <a:endParaRPr lang="en-US" sz="900" dirty="0"/>
                     </a:p>
@@ -5617,6 +6053,313 @@
                     </a:lnB>
                     <a:solidFill>
                       <a:srgbClr val="FFFFFF"/>
+                    </a:solidFill>
+                  </a:tcPr>
+                </a:tc>
+              </a:tr>
+              <a:tr h="384048">
+                <a:tc>
+                  <a:txBody>
+                    <a:bodyPr/>
+                    <a:lstStyle/>
+                    <a:p>
+                      <a:pPr indent="0" marL="0">
+                        <a:buNone/>
+                      </a:pPr>
+                      <a:r>
+                        <a:rPr lang="en-US" sz="900" b="1" dirty="0">
+                          <a:solidFill>
+                            <a:srgbClr val="1B2A41"/>
+                          </a:solidFill>
+                        </a:rPr>
+                        <a:t>Total</a:t>
+                      </a:r>
+                      <a:endParaRPr lang="en-US" sz="900" dirty="0"/>
+                    </a:p>
+                  </a:txBody>
+                  <a:tcPr marL="73152" marR="73152" marT="73152" marB="73152">
+                    <a:lnL w="6350" cap="flat" cmpd="sng" algn="ctr">
+                      <a:solidFill>
+                        <a:srgbClr val="D8DEE8"/>
+                      </a:solidFill>
+                      <a:prstDash val="solid"/>
+                      <a:round/>
+                      <a:headEnd type="none" w="med" len="med"/>
+                      <a:tailEnd type="none" w="med" len="med"/>
+                    </a:lnL>
+                    <a:lnR w="6350" cap="flat" cmpd="sng" algn="ctr">
+                      <a:solidFill>
+                        <a:srgbClr val="D8DEE8"/>
+                      </a:solidFill>
+                      <a:prstDash val="solid"/>
+                      <a:round/>
+                      <a:headEnd type="none" w="med" len="med"/>
+                      <a:tailEnd type="none" w="med" len="med"/>
+                    </a:lnR>
+                    <a:lnT w="13970" cap="flat" cmpd="sng" algn="ctr">
+                      <a:solidFill>
+                        <a:srgbClr val="1B2A41"/>
+                      </a:solidFill>
+                      <a:prstDash val="solid"/>
+                      <a:round/>
+                      <a:headEnd type="none" w="med" len="med"/>
+                      <a:tailEnd type="none" w="med" len="med"/>
+                    </a:lnT>
+                    <a:lnB w="6350" cap="flat" cmpd="sng" algn="ctr">
+                      <a:solidFill>
+                        <a:srgbClr val="D8DEE8"/>
+                      </a:solidFill>
+                      <a:prstDash val="solid"/>
+                      <a:round/>
+                      <a:headEnd type="none" w="med" len="med"/>
+                      <a:tailEnd type="none" w="med" len="med"/>
+                    </a:lnB>
+                    <a:solidFill>
+                      <a:srgbClr val="DCE6FA"/>
+                    </a:solidFill>
+                  </a:tcPr>
+                </a:tc>
+                <a:tc>
+                  <a:txBody>
+                    <a:bodyPr/>
+                    <a:lstStyle/>
+                    <a:p>
+                      <a:pPr indent="0" marL="0">
+                        <a:buNone/>
+                      </a:pPr>
+                      <a:r>
+                        <a:rPr lang="en-US" sz="900" b="1" dirty="0">
+                          <a:solidFill>
+                            <a:srgbClr val="1B2A41"/>
+                          </a:solidFill>
+                        </a:rPr>
+                        <a:t>5 roles</a:t>
+                      </a:r>
+                      <a:endParaRPr lang="en-US" sz="900" dirty="0"/>
+                    </a:p>
+                  </a:txBody>
+                  <a:tcPr marL="73152" marR="73152" marT="73152" marB="73152">
+                    <a:lnL w="6350" cap="flat" cmpd="sng" algn="ctr">
+                      <a:solidFill>
+                        <a:srgbClr val="D8DEE8"/>
+                      </a:solidFill>
+                      <a:prstDash val="solid"/>
+                      <a:round/>
+                      <a:headEnd type="none" w="med" len="med"/>
+                      <a:tailEnd type="none" w="med" len="med"/>
+                    </a:lnL>
+                    <a:lnR w="6350" cap="flat" cmpd="sng" algn="ctr">
+                      <a:solidFill>
+                        <a:srgbClr val="D8DEE8"/>
+                      </a:solidFill>
+                      <a:prstDash val="solid"/>
+                      <a:round/>
+                      <a:headEnd type="none" w="med" len="med"/>
+                      <a:tailEnd type="none" w="med" len="med"/>
+                    </a:lnR>
+                    <a:lnT w="13970" cap="flat" cmpd="sng" algn="ctr">
+                      <a:solidFill>
+                        <a:srgbClr val="1B2A41"/>
+                      </a:solidFill>
+                      <a:prstDash val="solid"/>
+                      <a:round/>
+                      <a:headEnd type="none" w="med" len="med"/>
+                      <a:tailEnd type="none" w="med" len="med"/>
+                    </a:lnT>
+                    <a:lnB w="6350" cap="flat" cmpd="sng" algn="ctr">
+                      <a:solidFill>
+                        <a:srgbClr val="D8DEE8"/>
+                      </a:solidFill>
+                      <a:prstDash val="solid"/>
+                      <a:round/>
+                      <a:headEnd type="none" w="med" len="med"/>
+                      <a:tailEnd type="none" w="med" len="med"/>
+                    </a:lnB>
+                    <a:solidFill>
+                      <a:srgbClr val="DCE6FA"/>
+                    </a:solidFill>
+                  </a:tcPr>
+                </a:tc>
+                <a:tc>
+                  <a:txBody>
+                    <a:bodyPr/>
+                    <a:lstStyle/>
+                    <a:p>
+                      <a:pPr indent="0" marL="0">
+                        <a:buNone/>
+                      </a:pPr>
+                      <a:r>
+                        <a:rPr lang="en-US" sz="900" b="1" dirty="0">
+                          <a:solidFill>
+                            <a:srgbClr val="1B2A41"/>
+                          </a:solidFill>
+                        </a:rPr>
+                        <a:t>3.3</a:t>
+                      </a:r>
+                      <a:endParaRPr lang="en-US" sz="900" dirty="0"/>
+                    </a:p>
+                  </a:txBody>
+                  <a:tcPr marL="73152" marR="73152" marT="73152" marB="73152">
+                    <a:lnL w="6350" cap="flat" cmpd="sng" algn="ctr">
+                      <a:solidFill>
+                        <a:srgbClr val="D8DEE8"/>
+                      </a:solidFill>
+                      <a:prstDash val="solid"/>
+                      <a:round/>
+                      <a:headEnd type="none" w="med" len="med"/>
+                      <a:tailEnd type="none" w="med" len="med"/>
+                    </a:lnL>
+                    <a:lnR w="6350" cap="flat" cmpd="sng" algn="ctr">
+                      <a:solidFill>
+                        <a:srgbClr val="D8DEE8"/>
+                      </a:solidFill>
+                      <a:prstDash val="solid"/>
+                      <a:round/>
+                      <a:headEnd type="none" w="med" len="med"/>
+                      <a:tailEnd type="none" w="med" len="med"/>
+                    </a:lnR>
+                    <a:lnT w="13970" cap="flat" cmpd="sng" algn="ctr">
+                      <a:solidFill>
+                        <a:srgbClr val="1B2A41"/>
+                      </a:solidFill>
+                      <a:prstDash val="solid"/>
+                      <a:round/>
+                      <a:headEnd type="none" w="med" len="med"/>
+                      <a:tailEnd type="none" w="med" len="med"/>
+                    </a:lnT>
+                    <a:lnB w="6350" cap="flat" cmpd="sng" algn="ctr">
+                      <a:solidFill>
+                        <a:srgbClr val="D8DEE8"/>
+                      </a:solidFill>
+                      <a:prstDash val="solid"/>
+                      <a:round/>
+                      <a:headEnd type="none" w="med" len="med"/>
+                      <a:tailEnd type="none" w="med" len="med"/>
+                    </a:lnB>
+                    <a:solidFill>
+                      <a:srgbClr val="DCE6FA"/>
+                    </a:solidFill>
+                  </a:tcPr>
+                </a:tc>
+                <a:tc>
+                  <a:txBody>
+                    <a:bodyPr/>
+                    <a:lstStyle/>
+                    <a:p>
+                      <a:pPr indent="0" marL="0">
+                        <a:buNone/>
+                      </a:pPr>
+                      <a:r>
+                        <a:rPr lang="en-US" sz="900" b="1" dirty="0">
+                          <a:solidFill>
+                            <a:srgbClr val="1B2A41"/>
+                          </a:solidFill>
+                        </a:rPr>
+                        <a:t>108</a:t>
+                      </a:r>
+                      <a:endParaRPr lang="en-US" sz="900" dirty="0"/>
+                    </a:p>
+                  </a:txBody>
+                  <a:tcPr marL="73152" marR="73152" marT="73152" marB="73152">
+                    <a:lnL w="6350" cap="flat" cmpd="sng" algn="ctr">
+                      <a:solidFill>
+                        <a:srgbClr val="D8DEE8"/>
+                      </a:solidFill>
+                      <a:prstDash val="solid"/>
+                      <a:round/>
+                      <a:headEnd type="none" w="med" len="med"/>
+                      <a:tailEnd type="none" w="med" len="med"/>
+                    </a:lnL>
+                    <a:lnR w="6350" cap="flat" cmpd="sng" algn="ctr">
+                      <a:solidFill>
+                        <a:srgbClr val="D8DEE8"/>
+                      </a:solidFill>
+                      <a:prstDash val="solid"/>
+                      <a:round/>
+                      <a:headEnd type="none" w="med" len="med"/>
+                      <a:tailEnd type="none" w="med" len="med"/>
+                    </a:lnR>
+                    <a:lnT w="13970" cap="flat" cmpd="sng" algn="ctr">
+                      <a:solidFill>
+                        <a:srgbClr val="1B2A41"/>
+                      </a:solidFill>
+                      <a:prstDash val="solid"/>
+                      <a:round/>
+                      <a:headEnd type="none" w="med" len="med"/>
+                      <a:tailEnd type="none" w="med" len="med"/>
+                    </a:lnT>
+                    <a:lnB w="6350" cap="flat" cmpd="sng" algn="ctr">
+                      <a:solidFill>
+                        <a:srgbClr val="D8DEE8"/>
+                      </a:solidFill>
+                      <a:prstDash val="solid"/>
+                      <a:round/>
+                      <a:headEnd type="none" w="med" len="med"/>
+                      <a:tailEnd type="none" w="med" len="med"/>
+                    </a:lnB>
+                    <a:solidFill>
+                      <a:srgbClr val="DCE6FA"/>
+                    </a:solidFill>
+                  </a:tcPr>
+                </a:tc>
+                <a:tc>
+                  <a:txBody>
+                    <a:bodyPr/>
+                    <a:lstStyle/>
+                    <a:p>
+                      <a:pPr indent="0" marL="0">
+                        <a:buNone/>
+                      </a:pPr>
+                      <a:r>
+                        <a:rPr lang="en-US" sz="900" b="1" dirty="0">
+                          <a:solidFill>
+                            <a:srgbClr val="1B2A41"/>
+                          </a:solidFill>
+                        </a:rPr>
+                        <a:t>Peak demand falls in Q4 2026</a:t>
+                      </a:r>
+                      <a:endParaRPr lang="en-US" sz="900" dirty="0"/>
+                    </a:p>
+                  </a:txBody>
+                  <a:tcPr marL="73152" marR="73152" marT="73152" marB="73152">
+                    <a:lnL w="6350" cap="flat" cmpd="sng" algn="ctr">
+                      <a:solidFill>
+                        <a:srgbClr val="D8DEE8"/>
+                      </a:solidFill>
+                      <a:prstDash val="solid"/>
+                      <a:round/>
+                      <a:headEnd type="none" w="med" len="med"/>
+                      <a:tailEnd type="none" w="med" len="med"/>
+                    </a:lnL>
+                    <a:lnR w="6350" cap="flat" cmpd="sng" algn="ctr">
+                      <a:solidFill>
+                        <a:srgbClr val="D8DEE8"/>
+                      </a:solidFill>
+                      <a:prstDash val="solid"/>
+                      <a:round/>
+                      <a:headEnd type="none" w="med" len="med"/>
+                      <a:tailEnd type="none" w="med" len="med"/>
+                    </a:lnR>
+                    <a:lnT w="13970" cap="flat" cmpd="sng" algn="ctr">
+                      <a:solidFill>
+                        <a:srgbClr val="1B2A41"/>
+                      </a:solidFill>
+                      <a:prstDash val="solid"/>
+                      <a:round/>
+                      <a:headEnd type="none" w="med" len="med"/>
+                      <a:tailEnd type="none" w="med" len="med"/>
+                    </a:lnT>
+                    <a:lnB w="6350" cap="flat" cmpd="sng" algn="ctr">
+                      <a:solidFill>
+                        <a:srgbClr val="D8DEE8"/>
+                      </a:solidFill>
+                      <a:prstDash val="solid"/>
+                      <a:round/>
+                      <a:headEnd type="none" w="med" len="med"/>
+                      <a:tailEnd type="none" w="med" len="med"/>
+                    </a:lnB>
+                    <a:solidFill>
+                      <a:srgbClr val="DCE6FA"/>
                     </a:solidFill>
                   </a:tcPr>
                 </a:tc>
@@ -6129,7 +6872,7 @@
                   <a:srgbClr val="667085"/>
                 </a:solidFill>
               </a:rPr>
-              <a:t>Source: Northwind KPI measurements · Jan–Jun 2026</a:t>
+              <a:t>Source: Northwind NW-OEE-L3 measurements · Jan–Jun 2026 · dump 11.09</a:t>
             </a:r>
             <a:endParaRPr lang="en-US" sz="650" dirty="0"/>
           </a:p>
@@ -6279,7 +7022,7 @@
             <a:avLst/>
           </a:prstGeom>
           <a:solidFill>
-            <a:srgbClr val="FFFFFF"/>
+            <a:srgbClr val="DCE6FA"/>
           </a:solidFill>
           <a:ln w="19050">
             <a:solidFill>
@@ -6371,8 +7114,8 @@
         </p:nvSpPr>
         <p:spPr>
           <a:xfrm>
-            <a:off x="1124712" y="2542032"/>
-            <a:ext cx="4480560" cy="749808"/>
+            <a:off x="1124712" y="2706624"/>
+            <a:ext cx="4480560" cy="566928"/>
           </a:xfrm>
           <a:prstGeom prst="rect">
             <a:avLst/>
@@ -6409,6 +7152,42 @@
         </p:nvSpPr>
         <p:spPr>
           <a:xfrm>
+            <a:off x="1124712" y="2432304"/>
+            <a:ext cx="4480560" cy="182880"/>
+          </a:xfrm>
+          <a:prstGeom prst="rect">
+            <a:avLst/>
+          </a:prstGeom>
+          <a:noFill/>
+          <a:ln/>
+        </p:spPr>
+        <p:txBody>
+          <a:bodyPr wrap="square" lIns="0" tIns="0" rIns="0" bIns="0" rtlCol="0" anchor="ctr"/>
+          <a:lstStyle/>
+          <a:p>
+            <a:pPr indent="0" marL="0">
+              <a:buNone/>
+            </a:pPr>
+            <a:r>
+              <a:rPr lang="en-US" sz="900" dirty="0">
+                <a:solidFill>
+                  <a:srgbClr val="667085"/>
+                </a:solidFill>
+              </a:rPr>
+              <a:t>£410k · MES Line 3</a:t>
+            </a:r>
+            <a:endParaRPr lang="en-US" sz="900" dirty="0"/>
+          </a:p>
+        </p:txBody>
+      </p:sp>
+      <p:sp>
+        <p:nvSpPr>
+          <p:cNvPr id="10" name="Text 8"/>
+          <p:cNvSpPr/>
+          <p:nvPr/>
+        </p:nvSpPr>
+        <p:spPr>
+          <a:xfrm>
             <a:off x="4389120" y="1618488"/>
             <a:ext cx="1188720" cy="256032"/>
           </a:xfrm>
@@ -6441,7 +7220,7 @@
       </p:sp>
       <p:sp>
         <p:nvSpPr>
-          <p:cNvPr id="10" name="Shape 8"/>
+          <p:cNvPr id="11" name="Shape 9"/>
           <p:cNvSpPr/>
           <p:nvPr/>
         </p:nvSpPr>
@@ -6466,7 +7245,7 @@
       </p:sp>
       <p:sp>
         <p:nvSpPr>
-          <p:cNvPr id="11" name="Text 9"/>
+          <p:cNvPr id="12" name="Text 10"/>
           <p:cNvSpPr/>
           <p:nvPr/>
         </p:nvSpPr>
@@ -6502,7 +7281,7 @@
       </p:sp>
       <p:sp>
         <p:nvSpPr>
-          <p:cNvPr id="12" name="Text 10"/>
+          <p:cNvPr id="13" name="Text 11"/>
           <p:cNvSpPr/>
           <p:nvPr/>
         </p:nvSpPr>
@@ -6540,14 +7319,14 @@
       </p:sp>
       <p:sp>
         <p:nvSpPr>
-          <p:cNvPr id="13" name="Text 11"/>
-          <p:cNvSpPr/>
-          <p:nvPr/>
-        </p:nvSpPr>
-        <p:spPr>
-          <a:xfrm>
-            <a:off x="6473952" y="2542032"/>
-            <a:ext cx="4480560" cy="749808"/>
+          <p:cNvPr id="14" name="Text 12"/>
+          <p:cNvSpPr/>
+          <p:nvPr/>
+        </p:nvSpPr>
+        <p:spPr>
+          <a:xfrm>
+            <a:off x="6473952" y="2706624"/>
+            <a:ext cx="4480560" cy="566928"/>
           </a:xfrm>
           <a:prstGeom prst="rect">
             <a:avLst/>
@@ -6578,7 +7357,43 @@
       </p:sp>
       <p:sp>
         <p:nvSpPr>
-          <p:cNvPr id="14" name="Shape 12"/>
+          <p:cNvPr id="15" name="Text 13"/>
+          <p:cNvSpPr/>
+          <p:nvPr/>
+        </p:nvSpPr>
+        <p:spPr>
+          <a:xfrm>
+            <a:off x="6473952" y="2432304"/>
+            <a:ext cx="4480560" cy="182880"/>
+          </a:xfrm>
+          <a:prstGeom prst="rect">
+            <a:avLst/>
+          </a:prstGeom>
+          <a:noFill/>
+          <a:ln/>
+        </p:spPr>
+        <p:txBody>
+          <a:bodyPr wrap="square" lIns="0" tIns="0" rIns="0" bIns="0" rtlCol="0" anchor="ctr"/>
+          <a:lstStyle/>
+          <a:p>
+            <a:pPr indent="0" marL="0">
+              <a:buNone/>
+            </a:pPr>
+            <a:r>
+              <a:rPr lang="en-US" sz="900" dirty="0">
+                <a:solidFill>
+                  <a:srgbClr val="667085"/>
+                </a:solidFill>
+              </a:rPr>
+              <a:t>£930k · MES + Warehouse</a:t>
+            </a:r>
+            <a:endParaRPr lang="en-US" sz="900" dirty="0"/>
+          </a:p>
+        </p:txBody>
+      </p:sp>
+      <p:sp>
+        <p:nvSpPr>
+          <p:cNvPr id="16" name="Shape 14"/>
           <p:cNvSpPr/>
           <p:nvPr/>
         </p:nvSpPr>
@@ -6603,7 +7418,7 @@
       </p:sp>
       <p:sp>
         <p:nvSpPr>
-          <p:cNvPr id="15" name="Shape 13"/>
+          <p:cNvPr id="17" name="Shape 15"/>
           <p:cNvSpPr/>
           <p:nvPr/>
         </p:nvSpPr>
@@ -6628,7 +7443,7 @@
       </p:sp>
       <p:sp>
         <p:nvSpPr>
-          <p:cNvPr id="16" name="Text 14"/>
+          <p:cNvPr id="18" name="Text 16"/>
           <p:cNvSpPr/>
           <p:nvPr/>
         </p:nvSpPr>
@@ -6664,7 +7479,7 @@
       </p:sp>
       <p:sp>
         <p:nvSpPr>
-          <p:cNvPr id="17" name="Text 15"/>
+          <p:cNvPr id="19" name="Text 17"/>
           <p:cNvSpPr/>
           <p:nvPr/>
         </p:nvSpPr>
@@ -6702,7 +7517,229 @@
       </p:sp>
       <p:sp>
         <p:nvSpPr>
-          <p:cNvPr id="18" name="Shape 16"/>
+          <p:cNvPr id="20" name="Text 18"/>
+          <p:cNvSpPr/>
+          <p:nvPr/>
+        </p:nvSpPr>
+        <p:spPr>
+          <a:xfrm>
+            <a:off x="868680" y="5358384"/>
+            <a:ext cx="3246120" cy="146304"/>
+          </a:xfrm>
+          <a:prstGeom prst="rect">
+            <a:avLst/>
+          </a:prstGeom>
+          <a:noFill/>
+          <a:ln/>
+        </p:spPr>
+        <p:txBody>
+          <a:bodyPr wrap="square" lIns="0" tIns="0" rIns="0" bIns="0" rtlCol="0" anchor="ctr"/>
+          <a:lstStyle/>
+          <a:p>
+            <a:pPr indent="0" marL="0">
+              <a:buNone/>
+            </a:pPr>
+            <a:r>
+              <a:rPr lang="en-US" sz="650" b="1" spc="80" kern="0" dirty="0">
+                <a:solidFill>
+                  <a:srgbClr val="667085"/>
+                </a:solidFill>
+              </a:rPr>
+              <a:t>DECISION OWNER</a:t>
+            </a:r>
+            <a:endParaRPr lang="en-US" sz="650" dirty="0"/>
+          </a:p>
+        </p:txBody>
+      </p:sp>
+      <p:sp>
+        <p:nvSpPr>
+          <p:cNvPr id="21" name="Text 19"/>
+          <p:cNvSpPr/>
+          <p:nvPr/>
+        </p:nvSpPr>
+        <p:spPr>
+          <a:xfrm>
+            <a:off x="868680" y="5559552"/>
+            <a:ext cx="3246120" cy="438912"/>
+          </a:xfrm>
+          <a:prstGeom prst="rect">
+            <a:avLst/>
+          </a:prstGeom>
+          <a:noFill/>
+          <a:ln/>
+        </p:spPr>
+        <p:txBody>
+          <a:bodyPr wrap="square" lIns="0" tIns="0" rIns="0" bIns="0" rtlCol="0" anchor="t">
+            <a:normAutofit/>
+          </a:bodyPr>
+          <a:lstStyle/>
+          <a:p>
+            <a:pPr indent="0" marL="0">
+              <a:buNone/>
+            </a:pPr>
+            <a:r>
+              <a:rPr lang="en-US" sz="900" dirty="0">
+                <a:solidFill>
+                  <a:srgbClr val="101828"/>
+                </a:solidFill>
+              </a:rPr>
+              <a:t>Board — Operations &amp; Capital Committee</a:t>
+            </a:r>
+            <a:endParaRPr lang="en-US" sz="900" dirty="0"/>
+          </a:p>
+        </p:txBody>
+      </p:sp>
+      <p:sp>
+        <p:nvSpPr>
+          <p:cNvPr id="22" name="Text 20"/>
+          <p:cNvSpPr/>
+          <p:nvPr/>
+        </p:nvSpPr>
+        <p:spPr>
+          <a:xfrm>
+            <a:off x="4328160" y="5358384"/>
+            <a:ext cx="3246120" cy="146304"/>
+          </a:xfrm>
+          <a:prstGeom prst="rect">
+            <a:avLst/>
+          </a:prstGeom>
+          <a:noFill/>
+          <a:ln/>
+        </p:spPr>
+        <p:txBody>
+          <a:bodyPr wrap="square" lIns="0" tIns="0" rIns="0" bIns="0" rtlCol="0" anchor="ctr"/>
+          <a:lstStyle/>
+          <a:p>
+            <a:pPr indent="0" marL="0">
+              <a:buNone/>
+            </a:pPr>
+            <a:r>
+              <a:rPr lang="en-US" sz="650" b="1" spc="80" kern="0" dirty="0">
+                <a:solidFill>
+                  <a:srgbClr val="667085"/>
+                </a:solidFill>
+              </a:rPr>
+              <a:t>DUE BY</a:t>
+            </a:r>
+            <a:endParaRPr lang="en-US" sz="650" dirty="0"/>
+          </a:p>
+        </p:txBody>
+      </p:sp>
+      <p:sp>
+        <p:nvSpPr>
+          <p:cNvPr id="23" name="Text 21"/>
+          <p:cNvSpPr/>
+          <p:nvPr/>
+        </p:nvSpPr>
+        <p:spPr>
+          <a:xfrm>
+            <a:off x="4328160" y="5559552"/>
+            <a:ext cx="3246120" cy="438912"/>
+          </a:xfrm>
+          <a:prstGeom prst="rect">
+            <a:avLst/>
+          </a:prstGeom>
+          <a:noFill/>
+          <a:ln/>
+        </p:spPr>
+        <p:txBody>
+          <a:bodyPr wrap="square" lIns="0" tIns="0" rIns="0" bIns="0" rtlCol="0" anchor="t">
+            <a:normAutofit/>
+          </a:bodyPr>
+          <a:lstStyle/>
+          <a:p>
+            <a:pPr indent="0" marL="0">
+              <a:buNone/>
+            </a:pPr>
+            <a:r>
+              <a:rPr lang="en-US" sz="900" dirty="0">
+                <a:solidFill>
+                  <a:srgbClr val="101828"/>
+                </a:solidFill>
+              </a:rPr>
+              <a:t>30 October 2026 (before summer shutdown planning)</a:t>
+            </a:r>
+            <a:endParaRPr lang="en-US" sz="900" dirty="0"/>
+          </a:p>
+        </p:txBody>
+      </p:sp>
+      <p:sp>
+        <p:nvSpPr>
+          <p:cNvPr id="24" name="Text 22"/>
+          <p:cNvSpPr/>
+          <p:nvPr/>
+        </p:nvSpPr>
+        <p:spPr>
+          <a:xfrm>
+            <a:off x="7787640" y="5358384"/>
+            <a:ext cx="3246120" cy="146304"/>
+          </a:xfrm>
+          <a:prstGeom prst="rect">
+            <a:avLst/>
+          </a:prstGeom>
+          <a:noFill/>
+          <a:ln/>
+        </p:spPr>
+        <p:txBody>
+          <a:bodyPr wrap="square" lIns="0" tIns="0" rIns="0" bIns="0" rtlCol="0" anchor="ctr"/>
+          <a:lstStyle/>
+          <a:p>
+            <a:pPr indent="0" marL="0">
+              <a:buNone/>
+            </a:pPr>
+            <a:r>
+              <a:rPr lang="en-US" sz="650" b="1" spc="80" kern="0" dirty="0">
+                <a:solidFill>
+                  <a:srgbClr val="667085"/>
+                </a:solidFill>
+              </a:rPr>
+              <a:t>LINKED RAID</a:t>
+            </a:r>
+            <a:endParaRPr lang="en-US" sz="650" dirty="0"/>
+          </a:p>
+        </p:txBody>
+      </p:sp>
+      <p:sp>
+        <p:nvSpPr>
+          <p:cNvPr id="25" name="Text 23"/>
+          <p:cNvSpPr/>
+          <p:nvPr/>
+        </p:nvSpPr>
+        <p:spPr>
+          <a:xfrm>
+            <a:off x="7787640" y="5559552"/>
+            <a:ext cx="3246120" cy="438912"/>
+          </a:xfrm>
+          <a:prstGeom prst="rect">
+            <a:avLst/>
+          </a:prstGeom>
+          <a:noFill/>
+          <a:ln/>
+        </p:spPr>
+        <p:txBody>
+          <a:bodyPr wrap="square" lIns="0" tIns="0" rIns="0" bIns="0" rtlCol="0" anchor="t">
+            <a:normAutofit/>
+          </a:bodyPr>
+          <a:lstStyle/>
+          <a:p>
+            <a:pPr indent="0" marL="0">
+              <a:buNone/>
+            </a:pPr>
+            <a:r>
+              <a:rPr lang="en-US" sz="900" dirty="0">
+                <a:solidFill>
+                  <a:srgbClr val="101828"/>
+                </a:solidFill>
+              </a:rPr>
+              <a:t>Cutover window is constrained by the summer shutdown date</a:t>
+            </a:r>
+            <a:endParaRPr lang="en-US" sz="900" dirty="0"/>
+          </a:p>
+        </p:txBody>
+      </p:sp>
+      <p:sp>
+        <p:nvSpPr>
+          <p:cNvPr id="26" name="Shape 24"/>
           <p:cNvSpPr/>
           <p:nvPr/>
         </p:nvSpPr>
@@ -6725,7 +7762,7 @@
       </p:sp>
       <p:sp>
         <p:nvSpPr>
-          <p:cNvPr id="19" name="Text 17"/>
+          <p:cNvPr id="27" name="Text 25"/>
           <p:cNvSpPr/>
           <p:nvPr/>
         </p:nvSpPr>
@@ -6761,7 +7798,7 @@
       </p:sp>
       <p:sp>
         <p:nvSpPr>
-          <p:cNvPr id="20" name="Text 18"/>
+          <p:cNvPr id="28" name="Text 26"/>
           <p:cNvSpPr/>
           <p:nvPr/>
         </p:nvSpPr>
@@ -6879,7 +7916,7 @@
         <a:font script="Viet" typeface="Times New Roman"/>
         <a:font script="Uigh" typeface="Microsoft Uighur"/>
         <a:font script="Geor" typeface="Sylfaen"/>
-        <a:font script="Armn" typeface="Arial"/>
+        <a:font script="Armn" typeface="+mn-lt"/>
         <a:font script="Bugi" typeface="Leelawadee UI"/>
         <a:font script="Bopo" typeface="Microsoft JhengHei"/>
         <a:font script="Java" typeface="Javanese Text"/>
@@ -6905,8 +7942,8 @@
         <a:font script="Hang" typeface="맑은 고딕"/>
         <a:font script="Hans" typeface="等线"/>
         <a:font script="Hant" typeface="新細明體"/>
-        <a:font script="Arab" typeface="Arial"/>
-        <a:font script="Hebr" typeface="Arial"/>
+        <a:font script="Arab" typeface="+mn-lt"/>
+        <a:font script="Hebr" typeface="+mn-lt"/>
         <a:font script="Thai" typeface="Cordia New"/>
         <a:font script="Ethi" typeface="Nyala"/>
         <a:font script="Beng" typeface="Vrinda"/>
@@ -6928,10 +7965,10 @@
         <a:font script="Laoo" typeface="DokChampa"/>
         <a:font script="Sinh" typeface="Iskoola Pota"/>
         <a:font script="Mong" typeface="Mongolian Baiti"/>
-        <a:font script="Viet" typeface="Arial"/>
+        <a:font script="Viet" typeface="+mn-lt"/>
         <a:font script="Uigh" typeface="Microsoft Uighur"/>
         <a:font script="Geor" typeface="Sylfaen"/>
-        <a:font script="Armn" typeface="Arial"/>
+        <a:font script="Armn" typeface="+mn-lt"/>
         <a:font script="Bugi" typeface="Leelawadee UI"/>
         <a:font script="Bopo" typeface="Microsoft JhengHei"/>
         <a:font script="Java" typeface="Javanese Text"/>

</xml_diff>

<commit_message>
fix(export): preserve canvas sections and decimal chart data [B]
</commit_message>
<xml_diff>
--- a/docs/program/EXPORT_1_PPTX_20260916/dowody/northwind-board-deck.pptx
+++ b/docs/program/EXPORT_1_PPTX_20260916/dowody/northwind-board-deck.pptx
@@ -148,7 +148,7 @@
           </c:spPr>
           <c:invertIfNegative val="0"/>
           <c:dLbls>
-            <c:numFmt formatCode="#,##0" sourceLinked="0"/>
+            <c:numFmt formatCode="0.0" sourceLinked="0"/>
             <c:txPr>
               <a:bodyPr/>
               <a:lstStyle/>
@@ -229,7 +229,7 @@
           </c:val>
         </c:ser>
         <c:dLbls>
-          <c:numFmt formatCode="#,##0" sourceLinked="0"/>
+          <c:numFmt formatCode="0.0" sourceLinked="0"/>
           <c:txPr>
             <a:bodyPr/>
             <a:lstStyle/>
@@ -475,7 +475,7 @@
             </a:ln>
           </c:spPr>
         </c:majorGridlines>
-        <c:numFmt formatCode="General" sourceLinked="0"/>
+        <c:numFmt formatCode="0.0" sourceLinked="0"/>
         <c:majorTickMark val="out"/>
         <c:minorTickMark val="none"/>
         <c:tickLblPos val="nextTo"/>
@@ -3241,14 +3241,39 @@
       </p:sp>
       <p:sp>
         <p:nvSpPr>
-          <p:cNvPr id="5" name="Text 3"/>
-          <p:cNvSpPr/>
-          <p:nvPr/>
-        </p:nvSpPr>
-        <p:spPr>
-          <a:xfrm>
-            <a:off x="960120" y="1444752"/>
-            <a:ext cx="10104120" cy="3429000"/>
+          <p:cNvPr id="5" name="Shape 3"/>
+          <p:cNvSpPr/>
+          <p:nvPr/>
+        </p:nvSpPr>
+        <p:spPr>
+          <a:xfrm>
+            <a:off x="886968" y="1517904"/>
+            <a:ext cx="91440" cy="91440"/>
+          </a:xfrm>
+          <a:prstGeom prst="rect">
+            <a:avLst/>
+          </a:prstGeom>
+          <a:solidFill>
+            <a:srgbClr val="2563EB"/>
+          </a:solidFill>
+          <a:ln w="12700">
+            <a:solidFill>
+              <a:srgbClr val="2563EB"/>
+            </a:solidFill>
+            <a:prstDash val="solid"/>
+          </a:ln>
+        </p:spPr>
+      </p:sp>
+      <p:sp>
+        <p:nvSpPr>
+          <p:cNvPr id="6" name="Text 4"/>
+          <p:cNvSpPr/>
+          <p:nvPr/>
+        </p:nvSpPr>
+        <p:spPr>
+          <a:xfrm>
+            <a:off x="1261872" y="1444752"/>
+            <a:ext cx="9802368" cy="877824"/>
           </a:xfrm>
           <a:prstGeom prst="rect">
             <a:avLst/>
@@ -3262,9 +3287,8 @@
           </a:bodyPr>
           <a:lstStyle/>
           <a:p>
-            <a:pPr marL="152400" indent="-152400">
-              <a:buSzPct val="100000"/>
-              <a:buChar char="•"/>
+            <a:pPr indent="0" marL="0">
+              <a:buNone/>
             </a:pPr>
             <a:r>
               <a:rPr lang="en-US" sz="1200" dirty="0">
@@ -3276,10 +3300,58 @@
             </a:r>
             <a:endParaRPr lang="en-US" sz="1200" dirty="0"/>
           </a:p>
-          <a:p>
-            <a:pPr marL="152400" indent="-152400">
-              <a:buSzPct val="100000"/>
-              <a:buChar char="•"/>
+        </p:txBody>
+      </p:sp>
+      <p:sp>
+        <p:nvSpPr>
+          <p:cNvPr id="7" name="Shape 5"/>
+          <p:cNvSpPr/>
+          <p:nvPr/>
+        </p:nvSpPr>
+        <p:spPr>
+          <a:xfrm>
+            <a:off x="886968" y="2468880"/>
+            <a:ext cx="91440" cy="91440"/>
+          </a:xfrm>
+          <a:prstGeom prst="rect">
+            <a:avLst/>
+          </a:prstGeom>
+          <a:solidFill>
+            <a:srgbClr val="2563EB"/>
+          </a:solidFill>
+          <a:ln w="12700">
+            <a:solidFill>
+              <a:srgbClr val="2563EB"/>
+            </a:solidFill>
+            <a:prstDash val="solid"/>
+          </a:ln>
+        </p:spPr>
+      </p:sp>
+      <p:sp>
+        <p:nvSpPr>
+          <p:cNvPr id="8" name="Text 6"/>
+          <p:cNvSpPr/>
+          <p:nvPr/>
+        </p:nvSpPr>
+        <p:spPr>
+          <a:xfrm>
+            <a:off x="1261872" y="2395728"/>
+            <a:ext cx="9802368" cy="877824"/>
+          </a:xfrm>
+          <a:prstGeom prst="rect">
+            <a:avLst/>
+          </a:prstGeom>
+          <a:noFill/>
+          <a:ln/>
+        </p:spPr>
+        <p:txBody>
+          <a:bodyPr wrap="square" lIns="0" tIns="0" rIns="0" bIns="0" rtlCol="0" anchor="t">
+            <a:normAutofit/>
+          </a:bodyPr>
+          <a:lstStyle/>
+          <a:p>
+            <a:pPr indent="0" marL="0">
+              <a:buNone/>
             </a:pPr>
             <a:r>
               <a:rPr lang="en-US" sz="1200" dirty="0">
@@ -3291,10 +3363,58 @@
             </a:r>
             <a:endParaRPr lang="en-US" sz="1200" dirty="0"/>
           </a:p>
-          <a:p>
-            <a:pPr marL="152400" indent="-152400">
-              <a:buSzPct val="100000"/>
-              <a:buChar char="•"/>
+        </p:txBody>
+      </p:sp>
+      <p:sp>
+        <p:nvSpPr>
+          <p:cNvPr id="9" name="Shape 7"/>
+          <p:cNvSpPr/>
+          <p:nvPr/>
+        </p:nvSpPr>
+        <p:spPr>
+          <a:xfrm>
+            <a:off x="886968" y="3419856"/>
+            <a:ext cx="91440" cy="91440"/>
+          </a:xfrm>
+          <a:prstGeom prst="rect">
+            <a:avLst/>
+          </a:prstGeom>
+          <a:solidFill>
+            <a:srgbClr val="2563EB"/>
+          </a:solidFill>
+          <a:ln w="12700">
+            <a:solidFill>
+              <a:srgbClr val="2563EB"/>
+            </a:solidFill>
+            <a:prstDash val="solid"/>
+          </a:ln>
+        </p:spPr>
+      </p:sp>
+      <p:sp>
+        <p:nvSpPr>
+          <p:cNvPr id="10" name="Text 8"/>
+          <p:cNvSpPr/>
+          <p:nvPr/>
+        </p:nvSpPr>
+        <p:spPr>
+          <a:xfrm>
+            <a:off x="1261872" y="3346704"/>
+            <a:ext cx="9802368" cy="877824"/>
+          </a:xfrm>
+          <a:prstGeom prst="rect">
+            <a:avLst/>
+          </a:prstGeom>
+          <a:noFill/>
+          <a:ln/>
+        </p:spPr>
+        <p:txBody>
+          <a:bodyPr wrap="square" lIns="0" tIns="0" rIns="0" bIns="0" rtlCol="0" anchor="t">
+            <a:normAutofit/>
+          </a:bodyPr>
+          <a:lstStyle/>
+          <a:p>
+            <a:pPr indent="0" marL="0">
+              <a:buNone/>
             </a:pPr>
             <a:r>
               <a:rPr lang="en-US" sz="1200" dirty="0">
@@ -3310,7 +3430,7 @@
       </p:sp>
       <p:sp>
         <p:nvSpPr>
-          <p:cNvPr id="6" name="Shape 4"/>
+          <p:cNvPr id="11" name="Shape 9"/>
           <p:cNvSpPr/>
           <p:nvPr/>
         </p:nvSpPr>
@@ -3335,7 +3455,7 @@
       </p:sp>
       <p:sp>
         <p:nvSpPr>
-          <p:cNvPr id="7" name="Shape 5"/>
+          <p:cNvPr id="12" name="Shape 10"/>
           <p:cNvSpPr/>
           <p:nvPr/>
         </p:nvSpPr>
@@ -3360,7 +3480,7 @@
       </p:sp>
       <p:sp>
         <p:nvSpPr>
-          <p:cNvPr id="8" name="Text 6"/>
+          <p:cNvPr id="13" name="Text 11"/>
           <p:cNvSpPr/>
           <p:nvPr/>
         </p:nvSpPr>
@@ -3396,7 +3516,7 @@
       </p:sp>
       <p:sp>
         <p:nvSpPr>
-          <p:cNvPr id="9" name="Text 7"/>
+          <p:cNvPr id="14" name="Text 12"/>
           <p:cNvSpPr/>
           <p:nvPr/>
         </p:nvSpPr>
@@ -3434,7 +3554,7 @@
       </p:sp>
       <p:sp>
         <p:nvSpPr>
-          <p:cNvPr id="10" name="Shape 8"/>
+          <p:cNvPr id="15" name="Shape 13"/>
           <p:cNvSpPr/>
           <p:nvPr/>
         </p:nvSpPr>
@@ -3457,7 +3577,7 @@
       </p:sp>
       <p:sp>
         <p:nvSpPr>
-          <p:cNvPr id="11" name="Text 9"/>
+          <p:cNvPr id="16" name="Text 14"/>
           <p:cNvSpPr/>
           <p:nvPr/>
         </p:nvSpPr>
@@ -3493,7 +3613,7 @@
       </p:sp>
       <p:sp>
         <p:nvSpPr>
-          <p:cNvPr id="12" name="Text 10"/>
+          <p:cNvPr id="17" name="Text 15"/>
           <p:cNvSpPr/>
           <p:nvPr/>
         </p:nvSpPr>
@@ -4528,7 +4648,7 @@
                     <a:bodyPr/>
                     <a:lstStyle/>
                     <a:p>
-                      <a:pPr indent="0" marL="0">
+                      <a:pPr algn="l" indent="0" marL="0">
                         <a:buNone/>
                       </a:pPr>
                       <a:r>
@@ -4589,7 +4709,7 @@
                     <a:bodyPr/>
                     <a:lstStyle/>
                     <a:p>
-                      <a:pPr indent="0" marL="0">
+                      <a:pPr algn="l" indent="0" marL="0">
                         <a:buNone/>
                       </a:pPr>
                       <a:r>
@@ -4650,7 +4770,7 @@
                     <a:bodyPr/>
                     <a:lstStyle/>
                     <a:p>
-                      <a:pPr indent="0" marL="0">
+                      <a:pPr algn="r" indent="0" marL="0">
                         <a:buNone/>
                       </a:pPr>
                       <a:r>
@@ -4711,7 +4831,7 @@
                     <a:bodyPr/>
                     <a:lstStyle/>
                     <a:p>
-                      <a:pPr indent="0" marL="0">
+                      <a:pPr algn="r" indent="0" marL="0">
                         <a:buNone/>
                       </a:pPr>
                       <a:r>
@@ -4772,7 +4892,7 @@
                     <a:bodyPr/>
                     <a:lstStyle/>
                     <a:p>
-                      <a:pPr indent="0" marL="0">
+                      <a:pPr algn="l" indent="0" marL="0">
                         <a:buNone/>
                       </a:pPr>
                       <a:r>
@@ -4835,7 +4955,7 @@
                     <a:bodyPr/>
                     <a:lstStyle/>
                     <a:p>
-                      <a:pPr indent="0" marL="0">
+                      <a:pPr algn="l" indent="0" marL="0">
                         <a:buNone/>
                       </a:pPr>
                       <a:r>
@@ -4896,7 +5016,7 @@
                     <a:bodyPr/>
                     <a:lstStyle/>
                     <a:p>
-                      <a:pPr indent="0" marL="0">
+                      <a:pPr algn="l" indent="0" marL="0">
                         <a:buNone/>
                       </a:pPr>
                       <a:r>
@@ -4957,7 +5077,7 @@
                     <a:bodyPr/>
                     <a:lstStyle/>
                     <a:p>
-                      <a:pPr indent="0" marL="0">
+                      <a:pPr algn="r" indent="0" marL="0">
                         <a:buNone/>
                       </a:pPr>
                       <a:r>
@@ -4966,7 +5086,7 @@
                             <a:srgbClr val="101828"/>
                           </a:solidFill>
                         </a:rPr>
-                        <a:t>1</a:t>
+                        <a:t>1.0</a:t>
                       </a:r>
                       <a:endParaRPr lang="en-US" sz="900" dirty="0"/>
                     </a:p>
@@ -5018,7 +5138,7 @@
                     <a:bodyPr/>
                     <a:lstStyle/>
                     <a:p>
-                      <a:pPr indent="0" marL="0">
+                      <a:pPr algn="r" indent="0" marL="0">
                         <a:buNone/>
                       </a:pPr>
                       <a:r>
@@ -5079,7 +5199,7 @@
                     <a:bodyPr/>
                     <a:lstStyle/>
                     <a:p>
-                      <a:pPr indent="0" marL="0">
+                      <a:pPr algn="l" indent="0" marL="0">
                         <a:buNone/>
                       </a:pPr>
                       <a:r>
@@ -5142,7 +5262,7 @@
                     <a:bodyPr/>
                     <a:lstStyle/>
                     <a:p>
-                      <a:pPr indent="0" marL="0">
+                      <a:pPr algn="l" indent="0" marL="0">
                         <a:buNone/>
                       </a:pPr>
                       <a:r>
@@ -5203,7 +5323,7 @@
                     <a:bodyPr/>
                     <a:lstStyle/>
                     <a:p>
-                      <a:pPr indent="0" marL="0">
+                      <a:pPr algn="l" indent="0" marL="0">
                         <a:buNone/>
                       </a:pPr>
                       <a:r>
@@ -5264,7 +5384,7 @@
                     <a:bodyPr/>
                     <a:lstStyle/>
                     <a:p>
-                      <a:pPr indent="0" marL="0">
+                      <a:pPr algn="r" indent="0" marL="0">
                         <a:buNone/>
                       </a:pPr>
                       <a:r>
@@ -5325,7 +5445,7 @@
                     <a:bodyPr/>
                     <a:lstStyle/>
                     <a:p>
-                      <a:pPr indent="0" marL="0">
+                      <a:pPr algn="r" indent="0" marL="0">
                         <a:buNone/>
                       </a:pPr>
                       <a:r>
@@ -5386,7 +5506,7 @@
                     <a:bodyPr/>
                     <a:lstStyle/>
                     <a:p>
-                      <a:pPr indent="0" marL="0">
+                      <a:pPr algn="l" indent="0" marL="0">
                         <a:buNone/>
                       </a:pPr>
                       <a:r>
@@ -5449,7 +5569,7 @@
                     <a:bodyPr/>
                     <a:lstStyle/>
                     <a:p>
-                      <a:pPr indent="0" marL="0">
+                      <a:pPr algn="l" indent="0" marL="0">
                         <a:buNone/>
                       </a:pPr>
                       <a:r>
@@ -5510,7 +5630,7 @@
                     <a:bodyPr/>
                     <a:lstStyle/>
                     <a:p>
-                      <a:pPr indent="0" marL="0">
+                      <a:pPr algn="l" indent="0" marL="0">
                         <a:buNone/>
                       </a:pPr>
                       <a:r>
@@ -5571,7 +5691,7 @@
                     <a:bodyPr/>
                     <a:lstStyle/>
                     <a:p>
-                      <a:pPr indent="0" marL="0">
+                      <a:pPr algn="r" indent="0" marL="0">
                         <a:buNone/>
                       </a:pPr>
                       <a:r>
@@ -5580,7 +5700,7 @@
                             <a:srgbClr val="101828"/>
                           </a:solidFill>
                         </a:rPr>
-                        <a:t>1</a:t>
+                        <a:t>1.0</a:t>
                       </a:r>
                       <a:endParaRPr lang="en-US" sz="900" dirty="0"/>
                     </a:p>
@@ -5632,7 +5752,7 @@
                     <a:bodyPr/>
                     <a:lstStyle/>
                     <a:p>
-                      <a:pPr indent="0" marL="0">
+                      <a:pPr algn="r" indent="0" marL="0">
                         <a:buNone/>
                       </a:pPr>
                       <a:r>
@@ -5693,7 +5813,7 @@
                     <a:bodyPr/>
                     <a:lstStyle/>
                     <a:p>
-                      <a:pPr indent="0" marL="0">
+                      <a:pPr algn="l" indent="0" marL="0">
                         <a:buNone/>
                       </a:pPr>
                       <a:r>
@@ -5756,7 +5876,7 @@
                     <a:bodyPr/>
                     <a:lstStyle/>
                     <a:p>
-                      <a:pPr indent="0" marL="0">
+                      <a:pPr algn="l" indent="0" marL="0">
                         <a:buNone/>
                       </a:pPr>
                       <a:r>
@@ -5817,7 +5937,7 @@
                     <a:bodyPr/>
                     <a:lstStyle/>
                     <a:p>
-                      <a:pPr indent="0" marL="0">
+                      <a:pPr algn="l" indent="0" marL="0">
                         <a:buNone/>
                       </a:pPr>
                       <a:r>
@@ -5878,7 +5998,7 @@
                     <a:bodyPr/>
                     <a:lstStyle/>
                     <a:p>
-                      <a:pPr indent="0" marL="0">
+                      <a:pPr algn="r" indent="0" marL="0">
                         <a:buNone/>
                       </a:pPr>
                       <a:r>
@@ -5939,7 +6059,7 @@
                     <a:bodyPr/>
                     <a:lstStyle/>
                     <a:p>
-                      <a:pPr indent="0" marL="0">
+                      <a:pPr algn="r" indent="0" marL="0">
                         <a:buNone/>
                       </a:pPr>
                       <a:r>
@@ -6000,7 +6120,7 @@
                     <a:bodyPr/>
                     <a:lstStyle/>
                     <a:p>
-                      <a:pPr indent="0" marL="0">
+                      <a:pPr algn="l" indent="0" marL="0">
                         <a:buNone/>
                       </a:pPr>
                       <a:r>
@@ -6063,7 +6183,7 @@
                     <a:bodyPr/>
                     <a:lstStyle/>
                     <a:p>
-                      <a:pPr indent="0" marL="0">
+                      <a:pPr algn="l" indent="0" marL="0">
                         <a:buNone/>
                       </a:pPr>
                       <a:r>
@@ -6124,7 +6244,7 @@
                     <a:bodyPr/>
                     <a:lstStyle/>
                     <a:p>
-                      <a:pPr indent="0" marL="0">
+                      <a:pPr algn="l" indent="0" marL="0">
                         <a:buNone/>
                       </a:pPr>
                       <a:r>
@@ -6185,7 +6305,7 @@
                     <a:bodyPr/>
                     <a:lstStyle/>
                     <a:p>
-                      <a:pPr indent="0" marL="0">
+                      <a:pPr algn="r" indent="0" marL="0">
                         <a:buNone/>
                       </a:pPr>
                       <a:r>
@@ -6246,7 +6366,7 @@
                     <a:bodyPr/>
                     <a:lstStyle/>
                     <a:p>
-                      <a:pPr indent="0" marL="0">
+                      <a:pPr algn="r" indent="0" marL="0">
                         <a:buNone/>
                       </a:pPr>
                       <a:r>
@@ -6307,7 +6427,7 @@
                     <a:bodyPr/>
                     <a:lstStyle/>
                     <a:p>
-                      <a:pPr indent="0" marL="0">
+                      <a:pPr algn="l" indent="0" marL="0">
                         <a:buNone/>
                       </a:pPr>
                       <a:r>
@@ -6679,8 +6799,152 @@
         </p:nvSpPr>
         <p:spPr>
           <a:xfrm>
-            <a:off x="8366760" y="1874520"/>
-            <a:ext cx="2606040" cy="1234440"/>
+            <a:off x="8366760" y="1773936"/>
+            <a:ext cx="2606040" cy="182880"/>
+          </a:xfrm>
+          <a:prstGeom prst="rect">
+            <a:avLst/>
+          </a:prstGeom>
+          <a:noFill/>
+          <a:ln/>
+        </p:spPr>
+        <p:txBody>
+          <a:bodyPr wrap="square" lIns="0" tIns="0" rIns="0" bIns="0" rtlCol="0" anchor="ctr"/>
+          <a:lstStyle/>
+          <a:p>
+            <a:pPr indent="0" marL="0">
+              <a:buNone/>
+            </a:pPr>
+            <a:r>
+              <a:rPr lang="en-US" sz="700" b="1" spc="120" kern="0" dirty="0">
+                <a:solidFill>
+                  <a:srgbClr val="667085"/>
+                </a:solidFill>
+              </a:rPr>
+              <a:t>TARGET</a:t>
+            </a:r>
+            <a:endParaRPr lang="en-US" sz="700" dirty="0"/>
+          </a:p>
+        </p:txBody>
+      </p:sp>
+      <p:sp>
+        <p:nvSpPr>
+          <p:cNvPr id="8" name="Text 5"/>
+          <p:cNvSpPr/>
+          <p:nvPr/>
+        </p:nvSpPr>
+        <p:spPr>
+          <a:xfrm>
+            <a:off x="8366760" y="2084832"/>
+            <a:ext cx="2606040" cy="438912"/>
+          </a:xfrm>
+          <a:prstGeom prst="rect">
+            <a:avLst/>
+          </a:prstGeom>
+          <a:noFill/>
+          <a:ln/>
+        </p:spPr>
+        <p:txBody>
+          <a:bodyPr wrap="square" lIns="0" tIns="0" rIns="0" bIns="0" rtlCol="0" anchor="ctr"/>
+          <a:lstStyle/>
+          <a:p>
+            <a:pPr indent="0" marL="0">
+              <a:buNone/>
+            </a:pPr>
+            <a:r>
+              <a:rPr lang="en-US" sz="2100" b="1" dirty="0">
+                <a:solidFill>
+                  <a:srgbClr val="1B2A41"/>
+                </a:solidFill>
+              </a:rPr>
+              <a:t>78.0 %</a:t>
+            </a:r>
+            <a:endParaRPr lang="en-US" sz="2100" dirty="0"/>
+          </a:p>
+        </p:txBody>
+      </p:sp>
+      <p:sp>
+        <p:nvSpPr>
+          <p:cNvPr id="9" name="Text 6"/>
+          <p:cNvSpPr/>
+          <p:nvPr/>
+        </p:nvSpPr>
+        <p:spPr>
+          <a:xfrm>
+            <a:off x="8366760" y="2871216"/>
+            <a:ext cx="2606040" cy="182880"/>
+          </a:xfrm>
+          <a:prstGeom prst="rect">
+            <a:avLst/>
+          </a:prstGeom>
+          <a:noFill/>
+          <a:ln/>
+        </p:spPr>
+        <p:txBody>
+          <a:bodyPr wrap="square" lIns="0" tIns="0" rIns="0" bIns="0" rtlCol="0" anchor="ctr"/>
+          <a:lstStyle/>
+          <a:p>
+            <a:pPr indent="0" marL="0">
+              <a:buNone/>
+            </a:pPr>
+            <a:r>
+              <a:rPr lang="en-US" sz="700" b="1" spc="120" kern="0" dirty="0">
+                <a:solidFill>
+                  <a:srgbClr val="667085"/>
+                </a:solidFill>
+              </a:rPr>
+              <a:t>LATEST</a:t>
+            </a:r>
+            <a:endParaRPr lang="en-US" sz="700" dirty="0"/>
+          </a:p>
+        </p:txBody>
+      </p:sp>
+      <p:sp>
+        <p:nvSpPr>
+          <p:cNvPr id="10" name="Text 7"/>
+          <p:cNvSpPr/>
+          <p:nvPr/>
+        </p:nvSpPr>
+        <p:spPr>
+          <a:xfrm>
+            <a:off x="8366760" y="3182112"/>
+            <a:ext cx="2606040" cy="438912"/>
+          </a:xfrm>
+          <a:prstGeom prst="rect">
+            <a:avLst/>
+          </a:prstGeom>
+          <a:noFill/>
+          <a:ln/>
+        </p:spPr>
+        <p:txBody>
+          <a:bodyPr wrap="square" lIns="0" tIns="0" rIns="0" bIns="0" rtlCol="0" anchor="ctr"/>
+          <a:lstStyle/>
+          <a:p>
+            <a:pPr indent="0" marL="0">
+              <a:buNone/>
+            </a:pPr>
+            <a:r>
+              <a:rPr lang="en-US" sz="2100" b="1" dirty="0">
+                <a:solidFill>
+                  <a:srgbClr val="B45309"/>
+                </a:solidFill>
+              </a:rPr>
+              <a:t>76.2 %</a:t>
+            </a:r>
+            <a:endParaRPr lang="en-US" sz="2100" dirty="0"/>
+          </a:p>
+        </p:txBody>
+      </p:sp>
+      <p:sp>
+        <p:nvSpPr>
+          <p:cNvPr id="11" name="Text 8"/>
+          <p:cNvSpPr/>
+          <p:nvPr/>
+        </p:nvSpPr>
+        <p:spPr>
+          <a:xfrm>
+            <a:off x="8366760" y="3977640"/>
+            <a:ext cx="2606040" cy="1024128"/>
           </a:xfrm>
           <a:prstGeom prst="rect">
             <a:avLst/>
@@ -6698,56 +6962,20 @@
               <a:buNone/>
             </a:pPr>
             <a:r>
-              <a:rPr lang="en-US" sz="1500" b="1" dirty="0">
-                <a:solidFill>
-                  <a:srgbClr val="1B2A41"/>
+              <a:rPr lang="en-US" sz="950" dirty="0">
+                <a:solidFill>
+                  <a:srgbClr val="101828"/>
                 </a:solidFill>
               </a:rPr>
               <a:t>76.2% latest; the remaining gap is stable and measurable.</a:t>
             </a:r>
-            <a:endParaRPr lang="en-US" sz="1500" dirty="0"/>
-          </a:p>
-        </p:txBody>
-      </p:sp>
-      <p:sp>
-        <p:nvSpPr>
-          <p:cNvPr id="8" name="Text 5"/>
-          <p:cNvSpPr/>
-          <p:nvPr/>
-        </p:nvSpPr>
-        <p:spPr>
-          <a:xfrm>
-            <a:off x="8366760" y="3456432"/>
-            <a:ext cx="2606040" cy="320040"/>
-          </a:xfrm>
-          <a:prstGeom prst="rect">
-            <a:avLst/>
-          </a:prstGeom>
-          <a:noFill/>
-          <a:ln/>
-        </p:spPr>
-        <p:txBody>
-          <a:bodyPr wrap="square" lIns="0" tIns="0" rIns="0" bIns="0" rtlCol="0" anchor="ctr"/>
-          <a:lstStyle/>
-          <a:p>
-            <a:pPr indent="0" marL="0">
-              <a:buNone/>
-            </a:pPr>
-            <a:r>
-              <a:rPr lang="en-US" sz="1000" b="1" dirty="0">
-                <a:solidFill>
-                  <a:srgbClr val="2563EB"/>
-                </a:solidFill>
-              </a:rPr>
-              <a:t>Target 78%</a:t>
-            </a:r>
-            <a:endParaRPr lang="en-US" sz="1000" dirty="0"/>
-          </a:p>
-        </p:txBody>
-      </p:sp>
-      <p:sp>
-        <p:nvSpPr>
-          <p:cNvPr id="9" name="Shape 6"/>
+            <a:endParaRPr lang="en-US" sz="950" dirty="0"/>
+          </a:p>
+        </p:txBody>
+      </p:sp>
+      <p:sp>
+        <p:nvSpPr>
+          <p:cNvPr id="12" name="Shape 9"/>
           <p:cNvSpPr/>
           <p:nvPr/>
         </p:nvSpPr>
@@ -6770,7 +6998,7 @@
       </p:sp>
       <p:sp>
         <p:nvSpPr>
-          <p:cNvPr id="10" name="Text 7"/>
+          <p:cNvPr id="13" name="Text 10"/>
           <p:cNvSpPr/>
           <p:nvPr/>
         </p:nvSpPr>
@@ -6806,7 +7034,7 @@
       </p:sp>
       <p:sp>
         <p:nvSpPr>
-          <p:cNvPr id="11" name="Text 8"/>
+          <p:cNvPr id="14" name="Text 11"/>
           <p:cNvSpPr/>
           <p:nvPr/>
         </p:nvSpPr>
@@ -6842,7 +7070,7 @@
       </p:sp>
       <p:sp>
         <p:nvSpPr>
-          <p:cNvPr id="12" name="Text 9"/>
+          <p:cNvPr id="15" name="Text 12"/>
           <p:cNvSpPr/>
           <p:nvPr/>
         </p:nvSpPr>

</xml_diff>